<commit_message>
Add career-readiness stack, software house directory, field recommendation, tech dictionary, and auth/UI polish
Brings in the accumulated Career Readiness feature set (Autopilot, Interview
Rehearsal, Application Pipeline, AI-Resilience, Assessment Generator) plus
new additions: a moderated software house directory (Pakistan + international,
student-submitted/admin-approved), a capability-matrix-driven field
recommendation with AI + deterministic fallback, a searchable tech-term
dictionary with a confusing-terms comparison section, password strength
policy with a live checklist, admin user deletion with cascade cleanup and
audit logging, and a redesigned Ask AI chat UI (markdown rendering, avatars,
auto-resizing input).

Co-Authored-By: Claude Sonnet 5 <noreply@anthropic.com>
</commit_message>
<xml_diff>
--- a/hackathon/07_Investor_Pitch_Deck.pptx
+++ b/hackathon/07_Investor_Pitch_Deck.pptx
@@ -3923,7 +3923,7 @@
                 </a:solidFill>
                 <a:latin typeface="Calibri"/>
               </a:rPr>
-              <a:t>Career Autopilot™ killer demo</a:t>
+              <a:t>Career Readiness Stack™ killer demo</a:t>
             </a:r>
           </a:p>
           <a:p>
@@ -3934,7 +3934,7 @@
                 </a:solidFill>
                 <a:latin typeface="Calibri"/>
               </a:rPr>
-              <a:t>Paste any JD → hire-readiness score + 90-day plan. One-line demo, clear outcome metric, natural premium upsell.</a:t>
+              <a:t>Paste any JD → fit % + 90-day plan, then the same gap report drives a targeted assessment, a rehearsal with a scorecard, and a tracked response rate. One pasted JD, five compounding outputs, a natural premium upsell.</a:t>
             </a:r>
           </a:p>
         </p:txBody>
@@ -4344,6 +4344,38 @@
               <a:t>Portable, verifiable evidence for university applications, visa skill proof, and remote roles — no incumbent issues it.</a:t>
             </a:r>
           </a:p>
+          <a:p>
+            <a:pPr algn="l">
+              <a:spcAft>
+                <a:spcPts val="200"/>
+              </a:spcAft>
+            </a:pPr>
+            <a:r>
+              <a:rPr sz="1500" b="1">
+                <a:solidFill>
+                  <a:srgbClr val="0A0A0A"/>
+                </a:solidFill>
+                <a:latin typeface="Calibri"/>
+              </a:rPr>
+              <a:t>Interview Rehearsal Studio™ + Application Pipeline™</a:t>
+            </a:r>
+          </a:p>
+          <a:p>
+            <a:pPr algn="l">
+              <a:spcAft>
+                <a:spcPts val="1000"/>
+              </a:spcAft>
+            </a:pPr>
+            <a:r>
+              <a:rPr sz="1300" b="0">
+                <a:solidFill>
+                  <a:srgbClr val="444444"/>
+                </a:solidFill>
+                <a:latin typeface="Calibri"/>
+              </a:rPr>
+              <a:t>Free mock-interview loop with a scored trend, and a 6-stage application tracker with an honest server-computed response rate — both drive daily return visits without a paywall.</a:t>
+            </a:r>
+          </a:p>
         </p:txBody>
       </p:sp>
       <p:sp>
@@ -4919,7 +4951,7 @@
                 </a:solidFill>
                 <a:latin typeface="Calibri"/>
               </a:rPr>
-              <a:t>14-feature student experience + full admin console, all running end-to-end today.</a:t>
+              <a:t>17-feature student experience + full admin console, all running end-to-end today.</a:t>
             </a:r>
           </a:p>
           <a:p>
@@ -4935,7 +4967,7 @@
                 </a:solidFill>
                 <a:latin typeface="Calibri"/>
               </a:rPr>
-              <a:t>40/40 automated tests · 52/52 live API QA checks</a:t>
+              <a:t>113/113 automated tests · 53/53 live API QA checks</a:t>
             </a:r>
           </a:p>
           <a:p>

</xml_diff>